<commit_message>
docs: simplifica o escopo tecnico (Fases 4-6) e ajusta para turma de 4 grupos
- Fase 4: so o P0 e implementado (aula guiada); a criacao e so especificada.
- Fase 5: teste do P0 ja vem pronto; evidencia = cenario 🔴→🟢 no log do CI.
- Fase 6: gates informativos; ruleset e environment configurados pelo professor;
  F-10 (segredos) so analise + plano.
- docs/13 (opcional): como tornar bloqueante o gate do grupo.
- Turma com G1-G4; referencias ao dossie de exemplo do pacote 5 (docs/12).
- Rubrica, apostila, glossario, DOSSIE.md e slides das Aulas 7-9 alinhados.

Co-Authored-By: Claude Opus 5.5 <noreply@anthropic.com>
</commit_message>
<xml_diff>
--- a/aulas/aula-07-verificacao.pptx
+++ b/aulas/aula-07-verificacao.pptx
@@ -9772,7 +9772,7 @@
                 </a:solidFill>
                 <a:latin typeface="Open Sans"/>
               </a:rPr>
-              <a:t>o teste que exercita seu controle (ex.: A pede exame de B -&gt; 403, nada vazado).</a:t>
+              <a:t>o teste do seu P0 (já vem pronto): vermelho antes, verde depois.</a:t>
             </a:r>
           </a:p>
           <a:p>
@@ -9837,7 +9837,7 @@
                 </a:solidFill>
                 <a:latin typeface="Open Sans"/>
               </a:rPr>
-              <a:t>Gate bloqueante: </a:t>
+              <a:t>Gates: </a:t>
             </a:r>
             <a:r>
               <a:rPr sz="1800">
@@ -9846,7 +9846,7 @@
                 </a:solidFill>
                 <a:latin typeface="Open Sans"/>
               </a:rPr>
-              <a:t>torne bloqueante o gate da classe corrigida.</a:t>
+              <a:t>ficam informativos; ache o seu teste no log do CI.</a:t>
             </a:r>
           </a:p>
           <a:p>

</xml_diff>